<commit_message>
Updated Syllabus and Orientation
</commit_message>
<xml_diff>
--- a/lectures/01-Course-Orientation/CS1910_Course-Orientation_Lecture.pptx
+++ b/lectures/01-Course-Orientation/CS1910_Course-Orientation_Lecture.pptx
@@ -5,7 +5,7 @@
     <p:sldMasterId id="2147483696" r:id="rId1"/>
   </p:sldMasterIdLst>
   <p:notesMasterIdLst>
-    <p:notesMasterId r:id="rId42"/>
+    <p:notesMasterId r:id="rId40"/>
   </p:notesMasterIdLst>
   <p:sldIdLst>
     <p:sldId id="266" r:id="rId2"/>
@@ -39,15 +39,13 @@
     <p:sldId id="284" r:id="rId30"/>
     <p:sldId id="285" r:id="rId31"/>
     <p:sldId id="264" r:id="rId32"/>
-    <p:sldId id="305" r:id="rId33"/>
-    <p:sldId id="304" r:id="rId34"/>
-    <p:sldId id="269" r:id="rId35"/>
-    <p:sldId id="306" r:id="rId36"/>
-    <p:sldId id="267" r:id="rId37"/>
-    <p:sldId id="268" r:id="rId38"/>
-    <p:sldId id="274" r:id="rId39"/>
-    <p:sldId id="278" r:id="rId40"/>
-    <p:sldId id="277" r:id="rId41"/>
+    <p:sldId id="304" r:id="rId33"/>
+    <p:sldId id="269" r:id="rId34"/>
+    <p:sldId id="306" r:id="rId35"/>
+    <p:sldId id="267" r:id="rId36"/>
+    <p:sldId id="268" r:id="rId37"/>
+    <p:sldId id="274" r:id="rId38"/>
+    <p:sldId id="278" r:id="rId39"/>
   </p:sldIdLst>
   <p:sldSz cx="12192000" cy="6858000"/>
   <p:notesSz cx="6858000" cy="9144000"/>
@@ -157,7 +155,7 @@
 <file path=ppt/revisionInfo.xml><?xml version="1.0" encoding="utf-8"?>
 <p1510:revInfo xmlns:a="http://schemas.openxmlformats.org/drawingml/2006/main" xmlns:r="http://schemas.openxmlformats.org/officeDocument/2006/relationships" xmlns:p1510="http://schemas.microsoft.com/office/powerpoint/2015/10/main">
   <p1510:revLst>
-    <p1510:client id="{75550F60-FB72-42DB-9249-5EBB5DEE4456}" v="9" dt="2026-07-23T00:07:50.678"/>
+    <p1510:client id="{BF1BBAB6-5345-40ED-8B74-0897D64622F1}" v="17" dt="2026-09-03T18:19:25.474"/>
   </p1510:revLst>
 </p1510:revInfo>
 </file>
@@ -165,156 +163,269 @@
 <file path=ppt/changesInfos/changesInfo1.xml><?xml version="1.0" encoding="utf-8"?>
 <pc:chgInfo xmlns:a="http://schemas.openxmlformats.org/drawingml/2006/main" xmlns:r="http://schemas.openxmlformats.org/officeDocument/2006/relationships" xmlns:ac="http://schemas.microsoft.com/office/drawing/2013/main/command" xmlns:pc="http://schemas.microsoft.com/office/powerpoint/2013/main/command">
   <pc:docChgLst>
-    <pc:chgData name="Christopher Power" userId="83706efc-52ec-4aad-b93a-e27c6e901a30" providerId="ADAL" clId="{97D26654-64D5-4042-8583-A5886BB6B01E}"/>
-    <pc:docChg chg="undo custSel addSld delSld modSld sldOrd modShowInfo">
-      <pc:chgData name="Christopher Power" userId="83706efc-52ec-4aad-b93a-e27c6e901a30" providerId="ADAL" clId="{97D26654-64D5-4042-8583-A5886BB6B01E}" dt="2026-07-23T00:12:38.060" v="4428" actId="20577"/>
+    <pc:chgData name="Christopher Power" userId="83706efc-52ec-4aad-b93a-e27c6e901a30" providerId="ADAL" clId="{020B0DAE-24A7-40F8-9A5C-565589CDAAC4}"/>
+    <pc:docChg chg="undo custSel delSld modSld">
+      <pc:chgData name="Christopher Power" userId="83706efc-52ec-4aad-b93a-e27c6e901a30" providerId="ADAL" clId="{020B0DAE-24A7-40F8-9A5C-565589CDAAC4}" dt="2026-09-03T18:39:43.629" v="674" actId="47"/>
       <pc:docMkLst>
         <pc:docMk/>
       </pc:docMkLst>
       <pc:sldChg chg="modSp mod">
-        <pc:chgData name="Christopher Power" userId="83706efc-52ec-4aad-b93a-e27c6e901a30" providerId="ADAL" clId="{97D26654-64D5-4042-8583-A5886BB6B01E}" dt="2026-07-23T00:12:38.060" v="4428" actId="20577"/>
+        <pc:chgData name="Christopher Power" userId="83706efc-52ec-4aad-b93a-e27c6e901a30" providerId="ADAL" clId="{020B0DAE-24A7-40F8-9A5C-565589CDAAC4}" dt="2026-09-03T18:29:32.288" v="482" actId="20577"/>
         <pc:sldMkLst>
           <pc:docMk/>
-          <pc:sldMk cId="3002068836" sldId="256"/>
+          <pc:sldMk cId="2323063488" sldId="260"/>
         </pc:sldMkLst>
         <pc:spChg chg="mod">
-          <ac:chgData name="Christopher Power" userId="83706efc-52ec-4aad-b93a-e27c6e901a30" providerId="ADAL" clId="{97D26654-64D5-4042-8583-A5886BB6B01E}" dt="2026-07-23T00:12:38.060" v="4428" actId="20577"/>
+          <ac:chgData name="Christopher Power" userId="83706efc-52ec-4aad-b93a-e27c6e901a30" providerId="ADAL" clId="{020B0DAE-24A7-40F8-9A5C-565589CDAAC4}" dt="2026-09-03T18:29:32.288" v="482" actId="20577"/>
           <ac:spMkLst>
             <pc:docMk/>
-            <pc:sldMk cId="3002068836" sldId="256"/>
-            <ac:spMk id="2" creationId="{C93DC5BA-038A-1370-693A-933684213ED6}"/>
-          </ac:spMkLst>
-        </pc:spChg>
-        <pc:spChg chg="mod">
-          <ac:chgData name="Christopher Power" userId="83706efc-52ec-4aad-b93a-e27c6e901a30" providerId="ADAL" clId="{97D26654-64D5-4042-8583-A5886BB6B01E}" dt="2026-07-23T00:12:32.901" v="4403" actId="20577"/>
-          <ac:spMkLst>
-            <pc:docMk/>
-            <pc:sldMk cId="3002068836" sldId="256"/>
-            <ac:spMk id="3" creationId="{C5AB9C7C-BEF1-C07A-6A77-DBDD71480AAD}"/>
+            <pc:sldMk cId="2323063488" sldId="260"/>
+            <ac:spMk id="3" creationId="{D92DE33F-324D-AF1B-882E-65A57EAC2670}"/>
           </ac:spMkLst>
         </pc:spChg>
       </pc:sldChg>
-      <pc:sldChg chg="modSp">
-        <pc:chgData name="Christopher Power" userId="83706efc-52ec-4aad-b93a-e27c6e901a30" providerId="ADAL" clId="{97D26654-64D5-4042-8583-A5886BB6B01E}" dt="2026-07-23T00:06:15.264" v="4296"/>
+      <pc:sldChg chg="modSp mod">
+        <pc:chgData name="Christopher Power" userId="83706efc-52ec-4aad-b93a-e27c6e901a30" providerId="ADAL" clId="{020B0DAE-24A7-40F8-9A5C-565589CDAAC4}" dt="2026-09-03T18:28:57.386" v="469" actId="20577"/>
+        <pc:sldMkLst>
+          <pc:docMk/>
+          <pc:sldMk cId="2350308870" sldId="261"/>
+        </pc:sldMkLst>
+        <pc:spChg chg="mod">
+          <ac:chgData name="Christopher Power" userId="83706efc-52ec-4aad-b93a-e27c6e901a30" providerId="ADAL" clId="{020B0DAE-24A7-40F8-9A5C-565589CDAAC4}" dt="2026-09-03T18:28:57.386" v="469" actId="20577"/>
+          <ac:spMkLst>
+            <pc:docMk/>
+            <pc:sldMk cId="2350308870" sldId="261"/>
+            <ac:spMk id="3" creationId="{C4CC7416-BD23-B305-0133-20145A8FEAFA}"/>
+          </ac:spMkLst>
+        </pc:spChg>
+      </pc:sldChg>
+      <pc:sldChg chg="addSp modSp mod">
+        <pc:chgData name="Christopher Power" userId="83706efc-52ec-4aad-b93a-e27c6e901a30" providerId="ADAL" clId="{020B0DAE-24A7-40F8-9A5C-565589CDAAC4}" dt="2026-09-03T18:26:38.885" v="335" actId="20577"/>
         <pc:sldMkLst>
           <pc:docMk/>
           <pc:sldMk cId="122268572" sldId="262"/>
         </pc:sldMkLst>
+        <pc:spChg chg="add mod">
+          <ac:chgData name="Christopher Power" userId="83706efc-52ec-4aad-b93a-e27c6e901a30" providerId="ADAL" clId="{020B0DAE-24A7-40F8-9A5C-565589CDAAC4}" dt="2026-09-03T18:19:51.262" v="313" actId="20577"/>
+          <ac:spMkLst>
+            <pc:docMk/>
+            <pc:sldMk cId="122268572" sldId="262"/>
+            <ac:spMk id="5" creationId="{3194582F-8CBE-B3F5-8346-7A4D5AD6F5B1}"/>
+          </ac:spMkLst>
+        </pc:spChg>
         <pc:spChg chg="mod">
-          <ac:chgData name="Christopher Power" userId="83706efc-52ec-4aad-b93a-e27c6e901a30" providerId="ADAL" clId="{97D26654-64D5-4042-8583-A5886BB6B01E}" dt="2026-07-23T00:06:15.264" v="4296"/>
+          <ac:chgData name="Christopher Power" userId="83706efc-52ec-4aad-b93a-e27c6e901a30" providerId="ADAL" clId="{020B0DAE-24A7-40F8-9A5C-565589CDAAC4}" dt="2026-09-03T18:19:54.298" v="314" actId="20577"/>
           <ac:spMkLst>
             <pc:docMk/>
             <pc:sldMk cId="122268572" sldId="262"/>
             <ac:spMk id="7" creationId="{A7C18B57-8B72-5E6B-BF5A-32186B434DCF}"/>
           </ac:spMkLst>
         </pc:spChg>
-      </pc:sldChg>
-      <pc:sldChg chg="modSp">
-        <pc:chgData name="Christopher Power" userId="83706efc-52ec-4aad-b93a-e27c6e901a30" providerId="ADAL" clId="{97D26654-64D5-4042-8583-A5886BB6B01E}" dt="2026-07-23T00:06:15.264" v="4296"/>
-        <pc:sldMkLst>
-          <pc:docMk/>
-          <pc:sldMk cId="188635278" sldId="264"/>
-        </pc:sldMkLst>
         <pc:spChg chg="mod">
-          <ac:chgData name="Christopher Power" userId="83706efc-52ec-4aad-b93a-e27c6e901a30" providerId="ADAL" clId="{97D26654-64D5-4042-8583-A5886BB6B01E}" dt="2026-07-23T00:06:15.264" v="4296"/>
+          <ac:chgData name="Christopher Power" userId="83706efc-52ec-4aad-b93a-e27c6e901a30" providerId="ADAL" clId="{020B0DAE-24A7-40F8-9A5C-565589CDAAC4}" dt="2026-09-03T18:16:52.746" v="164" actId="20577"/>
           <ac:spMkLst>
             <pc:docMk/>
-            <pc:sldMk cId="188635278" sldId="264"/>
-            <ac:spMk id="4" creationId="{476A3373-32BB-D206-6AF7-3D06390EBDFB}"/>
+            <pc:sldMk cId="122268572" sldId="262"/>
+            <ac:spMk id="10" creationId="{952E1AC1-4325-7866-1921-541A41E49D42}"/>
           </ac:spMkLst>
         </pc:spChg>
         <pc:spChg chg="mod">
-          <ac:chgData name="Christopher Power" userId="83706efc-52ec-4aad-b93a-e27c6e901a30" providerId="ADAL" clId="{97D26654-64D5-4042-8583-A5886BB6B01E}" dt="2026-07-23T00:06:15.264" v="4296"/>
+          <ac:chgData name="Christopher Power" userId="83706efc-52ec-4aad-b93a-e27c6e901a30" providerId="ADAL" clId="{020B0DAE-24A7-40F8-9A5C-565589CDAAC4}" dt="2026-09-03T18:26:38.885" v="335" actId="20577"/>
           <ac:spMkLst>
             <pc:docMk/>
-            <pc:sldMk cId="188635278" sldId="264"/>
-            <ac:spMk id="14" creationId="{6F7F1D9C-215B-A511-6998-A08BDD0E31DA}"/>
+            <pc:sldMk cId="122268572" sldId="262"/>
+            <ac:spMk id="12" creationId="{B3EC712F-58E3-764E-32D3-0BB92E216FC3}"/>
+          </ac:spMkLst>
+        </pc:spChg>
+        <pc:graphicFrameChg chg="mod modGraphic">
+          <ac:chgData name="Christopher Power" userId="83706efc-52ec-4aad-b93a-e27c6e901a30" providerId="ADAL" clId="{020B0DAE-24A7-40F8-9A5C-565589CDAAC4}" dt="2026-09-03T18:19:11.573" v="241" actId="20577"/>
+          <ac:graphicFrameMkLst>
+            <pc:docMk/>
+            <pc:sldMk cId="122268572" sldId="262"/>
+            <ac:graphicFrameMk id="4" creationId="{024CF10F-4DA2-2A77-A2DC-AD3FD124B2BD}"/>
+          </ac:graphicFrameMkLst>
+        </pc:graphicFrameChg>
+        <pc:cxnChg chg="add mod">
+          <ac:chgData name="Christopher Power" userId="83706efc-52ec-4aad-b93a-e27c6e901a30" providerId="ADAL" clId="{020B0DAE-24A7-40F8-9A5C-565589CDAAC4}" dt="2026-09-03T18:19:28.588" v="245" actId="1076"/>
+          <ac:cxnSpMkLst>
+            <pc:docMk/>
+            <pc:sldMk cId="122268572" sldId="262"/>
+            <ac:cxnSpMk id="3" creationId="{3A0A1E92-17C6-9156-053C-1DA2BC43C7F4}"/>
+          </ac:cxnSpMkLst>
+        </pc:cxnChg>
+      </pc:sldChg>
+      <pc:sldChg chg="modSp mod">
+        <pc:chgData name="Christopher Power" userId="83706efc-52ec-4aad-b93a-e27c6e901a30" providerId="ADAL" clId="{020B0DAE-24A7-40F8-9A5C-565589CDAAC4}" dt="2026-09-03T18:20:17.878" v="325" actId="20577"/>
+        <pc:sldMkLst>
+          <pc:docMk/>
+          <pc:sldMk cId="1217478224" sldId="263"/>
+        </pc:sldMkLst>
+        <pc:spChg chg="mod">
+          <ac:chgData name="Christopher Power" userId="83706efc-52ec-4aad-b93a-e27c6e901a30" providerId="ADAL" clId="{020B0DAE-24A7-40F8-9A5C-565589CDAAC4}" dt="2026-09-03T18:20:17.878" v="325" actId="20577"/>
+          <ac:spMkLst>
+            <pc:docMk/>
+            <pc:sldMk cId="1217478224" sldId="263"/>
+            <ac:spMk id="3" creationId="{4D55D105-EFDE-539C-869F-B909057F0592}"/>
           </ac:spMkLst>
         </pc:spChg>
       </pc:sldChg>
-      <pc:sldChg chg="modSp add del mod">
-        <pc:chgData name="Christopher Power" userId="83706efc-52ec-4aad-b93a-e27c6e901a30" providerId="ADAL" clId="{97D26654-64D5-4042-8583-A5886BB6B01E}" dt="2026-07-23T00:06:41.798" v="4326" actId="20577"/>
+      <pc:sldChg chg="del">
+        <pc:chgData name="Christopher Power" userId="83706efc-52ec-4aad-b93a-e27c6e901a30" providerId="ADAL" clId="{020B0DAE-24A7-40F8-9A5C-565589CDAAC4}" dt="2026-09-03T18:39:43.629" v="674" actId="47"/>
         <pc:sldMkLst>
           <pc:docMk/>
-          <pc:sldMk cId="1144124753" sldId="266"/>
+          <pc:sldMk cId="4168177853" sldId="277"/>
+        </pc:sldMkLst>
+      </pc:sldChg>
+      <pc:sldChg chg="modSp mod">
+        <pc:chgData name="Christopher Power" userId="83706efc-52ec-4aad-b93a-e27c6e901a30" providerId="ADAL" clId="{020B0DAE-24A7-40F8-9A5C-565589CDAAC4}" dt="2026-09-03T18:28:18.794" v="354" actId="20577"/>
+        <pc:sldMkLst>
+          <pc:docMk/>
+          <pc:sldMk cId="8773762" sldId="287"/>
         </pc:sldMkLst>
         <pc:spChg chg="mod">
-          <ac:chgData name="Christopher Power" userId="83706efc-52ec-4aad-b93a-e27c6e901a30" providerId="ADAL" clId="{97D26654-64D5-4042-8583-A5886BB6B01E}" dt="2026-07-23T00:06:41.798" v="4326" actId="20577"/>
+          <ac:chgData name="Christopher Power" userId="83706efc-52ec-4aad-b93a-e27c6e901a30" providerId="ADAL" clId="{020B0DAE-24A7-40F8-9A5C-565589CDAAC4}" dt="2026-09-03T18:28:18.794" v="354" actId="20577"/>
           <ac:spMkLst>
             <pc:docMk/>
-            <pc:sldMk cId="1144124753" sldId="266"/>
-            <ac:spMk id="2" creationId="{20208222-6307-30E8-2244-5701A0AD47C2}"/>
+            <pc:sldMk cId="8773762" sldId="287"/>
+            <ac:spMk id="3" creationId="{59939830-C84C-C998-0BA6-EBC4B658E083}"/>
+          </ac:spMkLst>
+        </pc:spChg>
+      </pc:sldChg>
+      <pc:sldChg chg="modSp mod">
+        <pc:chgData name="Christopher Power" userId="83706efc-52ec-4aad-b93a-e27c6e901a30" providerId="ADAL" clId="{020B0DAE-24A7-40F8-9A5C-565589CDAAC4}" dt="2026-09-03T18:30:42.048" v="513" actId="20577"/>
+        <pc:sldMkLst>
+          <pc:docMk/>
+          <pc:sldMk cId="1199974937" sldId="288"/>
+        </pc:sldMkLst>
+        <pc:spChg chg="mod">
+          <ac:chgData name="Christopher Power" userId="83706efc-52ec-4aad-b93a-e27c6e901a30" providerId="ADAL" clId="{020B0DAE-24A7-40F8-9A5C-565589CDAAC4}" dt="2026-09-03T18:30:42.048" v="513" actId="20577"/>
+          <ac:spMkLst>
+            <pc:docMk/>
+            <pc:sldMk cId="1199974937" sldId="288"/>
+            <ac:spMk id="3" creationId="{FD7D5F8A-DD3A-959F-90B5-E87FD1DDA2D5}"/>
+          </ac:spMkLst>
+        </pc:spChg>
+      </pc:sldChg>
+      <pc:sldChg chg="modSp mod">
+        <pc:chgData name="Christopher Power" userId="83706efc-52ec-4aad-b93a-e27c6e901a30" providerId="ADAL" clId="{020B0DAE-24A7-40F8-9A5C-565589CDAAC4}" dt="2026-09-03T18:31:17.508" v="664" actId="20577"/>
+        <pc:sldMkLst>
+          <pc:docMk/>
+          <pc:sldMk cId="3254469506" sldId="289"/>
+        </pc:sldMkLst>
+        <pc:spChg chg="mod">
+          <ac:chgData name="Christopher Power" userId="83706efc-52ec-4aad-b93a-e27c6e901a30" providerId="ADAL" clId="{020B0DAE-24A7-40F8-9A5C-565589CDAAC4}" dt="2026-09-03T18:31:17.508" v="664" actId="20577"/>
+          <ac:spMkLst>
+            <pc:docMk/>
+            <pc:sldMk cId="3254469506" sldId="289"/>
+            <ac:spMk id="3" creationId="{F7AB469B-3607-8B18-0F17-07550545EF02}"/>
+          </ac:spMkLst>
+        </pc:spChg>
+      </pc:sldChg>
+      <pc:sldChg chg="modSp mod">
+        <pc:chgData name="Christopher Power" userId="83706efc-52ec-4aad-b93a-e27c6e901a30" providerId="ADAL" clId="{020B0DAE-24A7-40F8-9A5C-565589CDAAC4}" dt="2026-09-03T18:20:47.126" v="333" actId="20577"/>
+        <pc:sldMkLst>
+          <pc:docMk/>
+          <pc:sldMk cId="4006704977" sldId="290"/>
+        </pc:sldMkLst>
+        <pc:spChg chg="mod">
+          <ac:chgData name="Christopher Power" userId="83706efc-52ec-4aad-b93a-e27c6e901a30" providerId="ADAL" clId="{020B0DAE-24A7-40F8-9A5C-565589CDAAC4}" dt="2026-09-03T18:20:47.126" v="333" actId="20577"/>
+          <ac:spMkLst>
+            <pc:docMk/>
+            <pc:sldMk cId="4006704977" sldId="290"/>
+            <ac:spMk id="2" creationId="{75F36119-F120-305F-ECB3-EBA73CE17D4C}"/>
+          </ac:spMkLst>
+        </pc:spChg>
+      </pc:sldChg>
+      <pc:sldChg chg="modSp mod">
+        <pc:chgData name="Christopher Power" userId="83706efc-52ec-4aad-b93a-e27c6e901a30" providerId="ADAL" clId="{020B0DAE-24A7-40F8-9A5C-565589CDAAC4}" dt="2026-09-03T18:32:12.697" v="672" actId="20577"/>
+        <pc:sldMkLst>
+          <pc:docMk/>
+          <pc:sldMk cId="1662518105" sldId="295"/>
+        </pc:sldMkLst>
+        <pc:spChg chg="mod">
+          <ac:chgData name="Christopher Power" userId="83706efc-52ec-4aad-b93a-e27c6e901a30" providerId="ADAL" clId="{020B0DAE-24A7-40F8-9A5C-565589CDAAC4}" dt="2026-09-03T18:32:12.697" v="672" actId="20577"/>
+          <ac:spMkLst>
+            <pc:docMk/>
+            <pc:sldMk cId="1662518105" sldId="295"/>
+            <ac:spMk id="3" creationId="{3805030E-52CC-B383-06C2-64ED62CB9079}"/>
+          </ac:spMkLst>
+        </pc:spChg>
+      </pc:sldChg>
+      <pc:sldChg chg="modSp mod">
+        <pc:chgData name="Christopher Power" userId="83706efc-52ec-4aad-b93a-e27c6e901a30" providerId="ADAL" clId="{020B0DAE-24A7-40F8-9A5C-565589CDAAC4}" dt="2026-09-03T18:29:08.312" v="471" actId="20577"/>
+        <pc:sldMkLst>
+          <pc:docMk/>
+          <pc:sldMk cId="161095701" sldId="297"/>
+        </pc:sldMkLst>
+        <pc:spChg chg="mod">
+          <ac:chgData name="Christopher Power" userId="83706efc-52ec-4aad-b93a-e27c6e901a30" providerId="ADAL" clId="{020B0DAE-24A7-40F8-9A5C-565589CDAAC4}" dt="2026-09-03T18:29:08.312" v="471" actId="20577"/>
+          <ac:spMkLst>
+            <pc:docMk/>
+            <pc:sldMk cId="161095701" sldId="297"/>
+            <ac:spMk id="3" creationId="{00E17D8D-C162-C1A0-E345-86231FD6D889}"/>
+          </ac:spMkLst>
+        </pc:spChg>
+      </pc:sldChg>
+      <pc:sldChg chg="modSp mod">
+        <pc:chgData name="Christopher Power" userId="83706efc-52ec-4aad-b93a-e27c6e901a30" providerId="ADAL" clId="{020B0DAE-24A7-40F8-9A5C-565589CDAAC4}" dt="2026-09-03T18:31:31.261" v="666" actId="1076"/>
+        <pc:sldMkLst>
+          <pc:docMk/>
+          <pc:sldMk cId="3414665496" sldId="301"/>
+        </pc:sldMkLst>
+        <pc:spChg chg="mod">
+          <ac:chgData name="Christopher Power" userId="83706efc-52ec-4aad-b93a-e27c6e901a30" providerId="ADAL" clId="{020B0DAE-24A7-40F8-9A5C-565589CDAAC4}" dt="2026-09-03T18:31:29.152" v="665" actId="1076"/>
+          <ac:spMkLst>
+            <pc:docMk/>
+            <pc:sldMk cId="3414665496" sldId="301"/>
+            <ac:spMk id="4" creationId="{E7CBFD0A-BA31-986B-55F6-5053407B0B94}"/>
           </ac:spMkLst>
         </pc:spChg>
         <pc:spChg chg="mod">
-          <ac:chgData name="Christopher Power" userId="83706efc-52ec-4aad-b93a-e27c6e901a30" providerId="ADAL" clId="{97D26654-64D5-4042-8583-A5886BB6B01E}" dt="2026-07-23T00:06:33.258" v="4306" actId="20577"/>
+          <ac:chgData name="Christopher Power" userId="83706efc-52ec-4aad-b93a-e27c6e901a30" providerId="ADAL" clId="{020B0DAE-24A7-40F8-9A5C-565589CDAAC4}" dt="2026-09-03T18:31:31.261" v="666" actId="1076"/>
           <ac:spMkLst>
             <pc:docMk/>
-            <pc:sldMk cId="1144124753" sldId="266"/>
-            <ac:spMk id="3" creationId="{C9BD3A44-D666-194C-0B46-E1ECA20D95D5}"/>
+            <pc:sldMk cId="3414665496" sldId="301"/>
+            <ac:spMk id="5" creationId="{05F1B796-D673-9F46-716A-2DE67742298E}"/>
           </ac:spMkLst>
         </pc:spChg>
       </pc:sldChg>
-      <pc:sldChg chg="modSp">
-        <pc:chgData name="Christopher Power" userId="83706efc-52ec-4aad-b93a-e27c6e901a30" providerId="ADAL" clId="{97D26654-64D5-4042-8583-A5886BB6B01E}" dt="2026-07-23T00:06:15.264" v="4296"/>
+      <pc:sldChg chg="delSp modSp mod">
+        <pc:chgData name="Christopher Power" userId="83706efc-52ec-4aad-b93a-e27c6e901a30" providerId="ADAL" clId="{020B0DAE-24A7-40F8-9A5C-565589CDAAC4}" dt="2026-09-03T18:16:12.728" v="155" actId="14100"/>
         <pc:sldMkLst>
           <pc:docMk/>
-          <pc:sldMk cId="1101733798" sldId="294"/>
+          <pc:sldMk cId="3869190149" sldId="302"/>
         </pc:sldMkLst>
         <pc:spChg chg="mod">
-          <ac:chgData name="Christopher Power" userId="83706efc-52ec-4aad-b93a-e27c6e901a30" providerId="ADAL" clId="{97D26654-64D5-4042-8583-A5886BB6B01E}" dt="2026-07-23T00:06:15.264" v="4296"/>
+          <ac:chgData name="Christopher Power" userId="83706efc-52ec-4aad-b93a-e27c6e901a30" providerId="ADAL" clId="{020B0DAE-24A7-40F8-9A5C-565589CDAAC4}" dt="2026-09-03T18:16:12.728" v="155" actId="14100"/>
           <ac:spMkLst>
             <pc:docMk/>
-            <pc:sldMk cId="1101733798" sldId="294"/>
-            <ac:spMk id="8" creationId="{FB6552E1-D39C-F6EA-2A47-5917229AF5E8}"/>
+            <pc:sldMk cId="3869190149" sldId="302"/>
+            <ac:spMk id="4" creationId="{133821B8-089F-BDC1-5B7C-D34A6AA62BDC}"/>
+          </ac:spMkLst>
+        </pc:spChg>
+        <pc:spChg chg="del mod">
+          <ac:chgData name="Christopher Power" userId="83706efc-52ec-4aad-b93a-e27c6e901a30" providerId="ADAL" clId="{020B0DAE-24A7-40F8-9A5C-565589CDAAC4}" dt="2026-09-03T18:13:15.131" v="15" actId="478"/>
+          <ac:spMkLst>
+            <pc:docMk/>
+            <pc:sldMk cId="3869190149" sldId="302"/>
+            <ac:spMk id="5" creationId="{879FD1B7-91FD-12C1-8726-81861BE9F222}"/>
+          </ac:spMkLst>
+        </pc:spChg>
+        <pc:spChg chg="del mod">
+          <ac:chgData name="Christopher Power" userId="83706efc-52ec-4aad-b93a-e27c6e901a30" providerId="ADAL" clId="{020B0DAE-24A7-40F8-9A5C-565589CDAAC4}" dt="2026-09-03T18:13:20.356" v="16" actId="478"/>
+          <ac:spMkLst>
+            <pc:docMk/>
+            <pc:sldMk cId="3869190149" sldId="302"/>
+            <ac:spMk id="7" creationId="{DB9FA9FD-CC52-3EE2-5FCD-EAA2667B2044}"/>
           </ac:spMkLst>
         </pc:spChg>
       </pc:sldChg>
-      <pc:sldChg chg="modSp new del mod">
-        <pc:chgData name="Christopher Power" userId="83706efc-52ec-4aad-b93a-e27c6e901a30" providerId="ADAL" clId="{97D26654-64D5-4042-8583-A5886BB6B01E}" dt="2026-07-23T00:08:14.239" v="4380" actId="47"/>
+      <pc:sldChg chg="del">
+        <pc:chgData name="Christopher Power" userId="83706efc-52ec-4aad-b93a-e27c6e901a30" providerId="ADAL" clId="{020B0DAE-24A7-40F8-9A5C-565589CDAAC4}" dt="2026-09-03T18:32:31.817" v="673" actId="47"/>
         <pc:sldMkLst>
           <pc:docMk/>
-          <pc:sldMk cId="620853074" sldId="307"/>
+          <pc:sldMk cId="68935377" sldId="305"/>
         </pc:sldMkLst>
-        <pc:spChg chg="mod">
-          <ac:chgData name="Christopher Power" userId="83706efc-52ec-4aad-b93a-e27c6e901a30" providerId="ADAL" clId="{97D26654-64D5-4042-8583-A5886BB6B01E}" dt="2026-07-23T00:06:49.515" v="4346" actId="20577"/>
-          <ac:spMkLst>
-            <pc:docMk/>
-            <pc:sldMk cId="620853074" sldId="307"/>
-            <ac:spMk id="2" creationId="{AD267AA8-3E94-9EFE-7952-76B6843EC015}"/>
-          </ac:spMkLst>
-        </pc:spChg>
-        <pc:spChg chg="mod">
-          <ac:chgData name="Christopher Power" userId="83706efc-52ec-4aad-b93a-e27c6e901a30" providerId="ADAL" clId="{97D26654-64D5-4042-8583-A5886BB6B01E}" dt="2026-07-23T00:07:13.924" v="4350"/>
-          <ac:spMkLst>
-            <pc:docMk/>
-            <pc:sldMk cId="620853074" sldId="307"/>
-            <ac:spMk id="3" creationId="{A9D31A24-F00D-3174-F605-34A5AD06BEB5}"/>
-          </ac:spMkLst>
-        </pc:spChg>
-      </pc:sldChg>
-      <pc:sldChg chg="modSp add mod">
-        <pc:chgData name="Christopher Power" userId="83706efc-52ec-4aad-b93a-e27c6e901a30" providerId="ADAL" clId="{97D26654-64D5-4042-8583-A5886BB6B01E}" dt="2026-07-23T00:09:41.684" v="4395" actId="27636"/>
-        <pc:sldMkLst>
-          <pc:docMk/>
-          <pc:sldMk cId="189958695" sldId="308"/>
-        </pc:sldMkLst>
-        <pc:spChg chg="mod">
-          <ac:chgData name="Christopher Power" userId="83706efc-52ec-4aad-b93a-e27c6e901a30" providerId="ADAL" clId="{97D26654-64D5-4042-8583-A5886BB6B01E}" dt="2026-07-23T00:08:09.425" v="4379" actId="20577"/>
-          <ac:spMkLst>
-            <pc:docMk/>
-            <pc:sldMk cId="189958695" sldId="308"/>
-            <ac:spMk id="2" creationId="{7B4F90B6-7B43-8FC1-517D-4B2E67D12612}"/>
-          </ac:spMkLst>
-        </pc:spChg>
-        <pc:spChg chg="mod">
-          <ac:chgData name="Christopher Power" userId="83706efc-52ec-4aad-b93a-e27c6e901a30" providerId="ADAL" clId="{97D26654-64D5-4042-8583-A5886BB6B01E}" dt="2026-07-23T00:09:41.684" v="4395" actId="27636"/>
-          <ac:spMkLst>
-            <pc:docMk/>
-            <pc:sldMk cId="189958695" sldId="308"/>
-            <ac:spMk id="3" creationId="{027AFA69-B4EE-8AF8-6D2D-6302BDE8E292}"/>
-          </ac:spMkLst>
-        </pc:spChg>
       </pc:sldChg>
     </pc:docChg>
   </pc:docChgLst>
@@ -322,7 +433,7 @@
 </file>
 
 <file path=ppt/diagrams/colors1.xml><?xml version="1.0" encoding="utf-8"?>
-<dgm:colorsDef xmlns:dgm="http://schemas.openxmlformats.org/drawingml/2006/diagram" xmlns:a="http://schemas.openxmlformats.org/drawingml/2006/main" uniqueId="urn:microsoft.com/office/officeart/2005/8/colors/accent1_2">
+<dgm:colorsDef xmlns:dgm="http://schemas.openxmlformats.org/drawingml/2006/diagram" xmlns:a="http://schemas.openxmlformats.org/drawingml/2006/main" uniqueId="urn:microsoft.com/office/officeart/2005/8/colors/accent1_2#1">
   <dgm:title val=""/>
   <dgm:desc val=""/>
   <dgm:catLst>
@@ -1072,7 +1183,7 @@
 <dgm:dataModel xmlns:dgm="http://schemas.openxmlformats.org/drawingml/2006/diagram" xmlns:a="http://schemas.openxmlformats.org/drawingml/2006/main">
   <dgm:ptLst>
     <dgm:pt modelId="{75DD8F4B-B0A6-43B4-BDFD-FA2B63B76F54}" type="doc">
-      <dgm:prSet loTypeId="urn:microsoft.com/office/officeart/2016/7/layout/LinearArrowProcessNumbered" loCatId="process" qsTypeId="urn:microsoft.com/office/officeart/2005/8/quickstyle/simple2" qsCatId="simple" csTypeId="urn:microsoft.com/office/officeart/2005/8/colors/accent1_2" csCatId="accent1" phldr="1"/>
+      <dgm:prSet loTypeId="urn:microsoft.com/office/officeart/2016/7/layout/LinearArrowProcessNumbered" loCatId="process" qsTypeId="urn:microsoft.com/office/officeart/2005/8/quickstyle/simple2#1" qsCatId="simple" csTypeId="urn:microsoft.com/office/officeart/2005/8/colors/accent1_2#1" csCatId="accent1" phldr="1"/>
       <dgm:spPr/>
       <dgm:t>
         <a:bodyPr/>
@@ -2978,7 +3089,7 @@
 </file>
 
 <file path=ppt/diagrams/quickStyle1.xml><?xml version="1.0" encoding="utf-8"?>
-<dgm:styleDef xmlns:dgm="http://schemas.openxmlformats.org/drawingml/2006/diagram" xmlns:a="http://schemas.openxmlformats.org/drawingml/2006/main" uniqueId="urn:microsoft.com/office/officeart/2005/8/quickstyle/simple2">
+<dgm:styleDef xmlns:dgm="http://schemas.openxmlformats.org/drawingml/2006/diagram" xmlns:a="http://schemas.openxmlformats.org/drawingml/2006/main" uniqueId="urn:microsoft.com/office/officeart/2005/8/quickstyle/simple2#1">
   <dgm:title val=""/>
   <dgm:desc val=""/>
   <dgm:catLst>
@@ -4093,7 +4204,7 @@
           <a:p>
             <a:fld id="{34AA4B8C-BF6B-4440-8121-9D39C04872C3}" type="datetimeFigureOut">
               <a:rPr lang="en-US" smtClean="0"/>
-              <a:t>7/22/2026</a:t>
+              <a:t>9/3/2026</a:t>
             </a:fld>
             <a:endParaRPr lang="en-US"/>
           </a:p>
@@ -4523,7 +4634,7 @@
           <a:p>
             <a:fld id="{1160EA64-D806-43AC-9DF2-F8C432F32B4C}" type="datetimeFigureOut">
               <a:rPr lang="en-US" dirty="0"/>
-              <a:t>7/22/2026</a:t>
+              <a:t>9/3/2026</a:t>
             </a:fld>
             <a:endParaRPr lang="en-US" dirty="0"/>
           </a:p>
@@ -4689,7 +4800,7 @@
           <a:p>
             <a:fld id="{E9F9C37B-1D36-470B-8223-D6C91242EC14}" type="datetimeFigureOut">
               <a:rPr lang="en-US" dirty="0"/>
-              <a:t>7/22/2026</a:t>
+              <a:t>9/3/2026</a:t>
             </a:fld>
             <a:endParaRPr lang="en-US" dirty="0"/>
           </a:p>
@@ -4864,7 +4975,7 @@
           <a:p>
             <a:fld id="{67C6F52A-A82B-47A2-A83A-8C4C91F2D59F}" type="datetimeFigureOut">
               <a:rPr lang="en-US" dirty="0"/>
-              <a:t>7/22/2026</a:t>
+              <a:t>9/3/2026</a:t>
             </a:fld>
             <a:endParaRPr lang="en-US" dirty="0"/>
           </a:p>
@@ -5029,7 +5140,7 @@
           <a:p>
             <a:fld id="{F070A7B3-6521-4DCA-87E5-044747A908C1}" type="datetimeFigureOut">
               <a:rPr lang="en-US" dirty="0"/>
-              <a:t>7/22/2026</a:t>
+              <a:t>9/3/2026</a:t>
             </a:fld>
             <a:endParaRPr lang="en-US" dirty="0"/>
           </a:p>
@@ -5293,7 +5404,7 @@
           <a:p>
             <a:fld id="{1160EA64-D806-43AC-9DF2-F8C432F32B4C}" type="datetimeFigureOut">
               <a:rPr lang="en-US" dirty="0"/>
-              <a:t>7/22/2026</a:t>
+              <a:t>9/3/2026</a:t>
             </a:fld>
             <a:endParaRPr lang="en-US" dirty="0"/>
           </a:p>
@@ -5521,7 +5632,7 @@
           <a:p>
             <a:fld id="{AB134690-1557-4C89-A502-4959FE7FAD70}" type="datetimeFigureOut">
               <a:rPr lang="en-US" dirty="0"/>
-              <a:t>7/22/2026</a:t>
+              <a:t>9/3/2026</a:t>
             </a:fld>
             <a:endParaRPr lang="en-US" dirty="0"/>
           </a:p>
@@ -5875,7 +5986,7 @@
           <a:p>
             <a:fld id="{4F7D4976-E339-4826-83B7-FBD03F55ECF8}" type="datetimeFigureOut">
               <a:rPr lang="en-US" dirty="0"/>
-              <a:t>7/22/2026</a:t>
+              <a:t>9/3/2026</a:t>
             </a:fld>
             <a:endParaRPr lang="en-US" dirty="0"/>
           </a:p>
@@ -6011,7 +6122,7 @@
           <a:p>
             <a:fld id="{E1037C31-9E7A-4F99-8774-A0E530DE1A42}" type="datetimeFigureOut">
               <a:rPr lang="en-US" dirty="0"/>
-              <a:t>7/22/2026</a:t>
+              <a:t>9/3/2026</a:t>
             </a:fld>
             <a:endParaRPr lang="en-US" dirty="0"/>
           </a:p>
@@ -6101,7 +6212,7 @@
           <a:p>
             <a:fld id="{C278504F-A551-4DE0-9316-4DCD1D8CC752}" type="datetimeFigureOut">
               <a:rPr lang="en-US" dirty="0"/>
-              <a:t>7/22/2026</a:t>
+              <a:t>9/3/2026</a:t>
             </a:fld>
             <a:endParaRPr lang="en-US" dirty="0"/>
           </a:p>
@@ -6453,7 +6564,7 @@
           <a:p>
             <a:fld id="{D1BE4249-C0D0-4B06-8692-E8BB871AF643}" type="datetimeFigureOut">
               <a:rPr lang="en-US" dirty="0"/>
-              <a:t>7/22/2026</a:t>
+              <a:t>9/3/2026</a:t>
             </a:fld>
             <a:endParaRPr lang="en-US" dirty="0"/>
           </a:p>
@@ -6805,7 +6916,7 @@
           <a:p>
             <a:fld id="{042B0DB6-F5C7-45FB-8CF3-31B45F9C2DAC}" type="datetimeFigureOut">
               <a:rPr lang="en-US" dirty="0"/>
-              <a:t>7/22/2026</a:t>
+              <a:t>9/3/2026</a:t>
             </a:fld>
             <a:endParaRPr lang="en-US" dirty="0"/>
           </a:p>
@@ -7042,7 +7153,7 @@
           <a:p>
             <a:fld id="{1160EA64-D806-43AC-9DF2-F8C432F32B4C}" type="datetimeFigureOut">
               <a:rPr lang="en-US" dirty="0"/>
-              <a:t>7/22/2026</a:t>
+              <a:t>9/3/2026</a:t>
             </a:fld>
             <a:endParaRPr lang="en-US" dirty="0"/>
           </a:p>
@@ -7876,7 +7987,7 @@
           <a:p>
             <a:r>
               <a:rPr lang="en-US" dirty="0"/>
-              <a:t>Tests</a:t>
+              <a:t>Midterm Tests</a:t>
             </a:r>
           </a:p>
         </p:txBody>
@@ -8015,7 +8126,7 @@
         <p:spPr/>
         <p:txBody>
           <a:bodyPr>
-            <a:normAutofit fontScale="70000" lnSpcReduction="20000"/>
+            <a:normAutofit fontScale="92500" lnSpcReduction="20000"/>
           </a:bodyPr>
           <a:lstStyle/>
           <a:p>
@@ -8057,14 +8168,7 @@
             <a:pPr lvl="1"/>
             <a:r>
               <a:rPr lang="en-US" sz="1800" dirty="0"/>
-              <a:t>Normally, a first violation is loss of the marks on the marked component and an additional penalty of 50% of the mark of the component.  </a:t>
-            </a:r>
-          </a:p>
-          <a:p>
-            <a:pPr lvl="2"/>
-            <a:r>
-              <a:rPr lang="en-US" sz="1800" dirty="0"/>
-              <a:t>Example: Violation on a 10% component results in a loss of 15%</a:t>
+              <a:t>Normally, a first violation is loss of all marks on the component.</a:t>
             </a:r>
           </a:p>
           <a:p>
@@ -8398,7 +8502,7 @@
             <a:pPr lvl="1"/>
             <a:r>
               <a:rPr lang="en-US" sz="2000" dirty="0"/>
-              <a:t>Use of GenAI to answer exam or homework questions</a:t>
+              <a:t>Use of Generative AI to answer exam questions</a:t>
             </a:r>
           </a:p>
           <a:p>
@@ -8501,7 +8605,7 @@
         <p:spPr/>
         <p:txBody>
           <a:bodyPr>
-            <a:normAutofit/>
+            <a:normAutofit lnSpcReduction="10000"/>
           </a:bodyPr>
           <a:lstStyle/>
           <a:p>
@@ -8530,7 +8634,13 @@
           <a:p>
             <a:r>
               <a:rPr lang="en-US" dirty="0"/>
-              <a:t>For any aspects of the course – lecture, labs, assignments and tests - please come have a discussion accommodations with me to identify what alternatives will work best for you</a:t>
+              <a:t>For any aspects of the course – lecture, labs, assignments and tests - please come have a discussion accommodations with us to identify what alternatives will work best for you</a:t>
+            </a:r>
+          </a:p>
+          <a:p>
+            <a:r>
+              <a:rPr lang="en-US" dirty="0"/>
+              <a:t>Both midterms are already in the accommodate system already, and you can register for them right now!</a:t>
             </a:r>
           </a:p>
         </p:txBody>
@@ -9022,7 +9132,7 @@
             </a:pPr>
             <a:r>
               <a:rPr lang="en-US" sz="1800" dirty="0"/>
-              <a:t>4% of final grade is in-class participation</a:t>
+              <a:t>5% of final grade is in-class participation</a:t>
             </a:r>
           </a:p>
           <a:p>
@@ -9578,7 +9688,7 @@
           <a:p>
             <a:r>
               <a:rPr lang="en-US" dirty="0"/>
-              <a:t>Mandatory Attendance starting the week of January 19, 2026</a:t>
+              <a:t>Mandatory Attendance starting the week of September 14, 2026</a:t>
             </a:r>
           </a:p>
           <a:p>
@@ -9626,28 +9736,28 @@
           <a:p>
             <a:r>
               <a:rPr lang="en-US" dirty="0"/>
-              <a:t>Labs are worth 18% of total grade</a:t>
+              <a:t>Labs are worth 12% of total grade</a:t>
             </a:r>
           </a:p>
           <a:p>
             <a:pPr lvl="1"/>
             <a:r>
               <a:rPr lang="en-US" dirty="0"/>
-              <a:t>9 Labs starting in Week 3</a:t>
+              <a:t>8-9 Labs starting in Week 2</a:t>
             </a:r>
           </a:p>
           <a:p>
             <a:pPr lvl="1"/>
             <a:r>
               <a:rPr lang="en-US" dirty="0"/>
-              <a:t>Attend and participate in the lab = 1 point</a:t>
+              <a:t>Attend and participate in the lab = 2 point</a:t>
             </a:r>
           </a:p>
           <a:p>
             <a:pPr lvl="1"/>
             <a:r>
               <a:rPr lang="en-US" dirty="0"/>
-              <a:t>Lab grade is out of 6 </a:t>
+              <a:t>Lab grade is out of 12 </a:t>
             </a:r>
           </a:p>
           <a:p>
@@ -9661,7 +9771,7 @@
             <a:pPr lvl="1"/>
             <a:r>
               <a:rPr lang="en-US" dirty="0"/>
-              <a:t>Attend and participate in 6 labs = earn 6/6 = 18% of final grade</a:t>
+              <a:t>Attend and participate in 6 labs = earn 12/12 = 12% of final grade</a:t>
             </a:r>
           </a:p>
           <a:p>
@@ -9746,12 +9856,14 @@
         </p:nvSpPr>
         <p:spPr/>
         <p:txBody>
-          <a:bodyPr/>
+          <a:bodyPr>
+            <a:normAutofit fontScale="92500" lnSpcReduction="20000"/>
+          </a:bodyPr>
           <a:lstStyle/>
           <a:p>
             <a:r>
               <a:rPr lang="en-US" dirty="0"/>
-              <a:t>Many weeks there will be an homework assignment that is intended to be independent work</a:t>
+              <a:t>Many weeks there will be a homework assignment that is intended to be independent work</a:t>
             </a:r>
           </a:p>
           <a:p>
@@ -9791,6 +9903,12 @@
             <a:r>
               <a:rPr lang="en-US" dirty="0"/>
               <a:t>These assignments help you integrate the top-down knowledge you are gaining in lecture with the bottom-up skills you gain in your lab and personal practice.</a:t>
+            </a:r>
+          </a:p>
+          <a:p>
+            <a:r>
+              <a:rPr lang="en-US" dirty="0"/>
+              <a:t>A first homework will be released this week to help you get used to the way we do these assignments and help you through any issues.</a:t>
             </a:r>
           </a:p>
         </p:txBody>
@@ -10366,7 +10484,7 @@
         </p:nvSpPr>
         <p:spPr>
           <a:xfrm>
-            <a:off x="2231136" y="5189520"/>
+            <a:off x="2464401" y="4722989"/>
             <a:ext cx="6968895" cy="369332"/>
           </a:xfrm>
           <a:prstGeom prst="rect">
@@ -10406,7 +10524,7 @@
         </p:nvSpPr>
         <p:spPr>
           <a:xfrm>
-            <a:off x="2231136" y="5750912"/>
+            <a:off x="2464401" y="5207621"/>
             <a:ext cx="7650877" cy="369332"/>
           </a:xfrm>
           <a:prstGeom prst="rect">
@@ -12329,7 +12447,7 @@
                   <a:schemeClr val="tx1"/>
                 </a:solidFill>
               </a:rPr>
-              <a:t>40% of grading is Labs, Participation and Homework</a:t>
+              <a:t>35% of grading is Labs, Participation and Homework</a:t>
             </a:r>
           </a:p>
           <a:p>
@@ -12361,7 +12479,7 @@
                   <a:schemeClr val="tx1"/>
                 </a:solidFill>
               </a:rPr>
-              <a:t>60% of grading is traditional tests </a:t>
+              <a:t>65% of grading is traditional tests </a:t>
             </a:r>
           </a:p>
           <a:p>
@@ -13878,221 +13996,6 @@
 </file>
 
 <file path=ppt/slides/slide32.xml><?xml version="1.0" encoding="utf-8"?>
-<p:sld xmlns:a="http://schemas.openxmlformats.org/drawingml/2006/main" xmlns:r="http://schemas.openxmlformats.org/officeDocument/2006/relationships" xmlns:p="http://schemas.openxmlformats.org/presentationml/2006/main">
-  <p:cSld>
-    <p:spTree>
-      <p:nvGrpSpPr>
-        <p:cNvPr id="1" name=""/>
-        <p:cNvGrpSpPr/>
-        <p:nvPr/>
-      </p:nvGrpSpPr>
-      <p:grpSpPr>
-        <a:xfrm>
-          <a:off x="0" y="0"/>
-          <a:ext cx="0" cy="0"/>
-          <a:chOff x="0" y="0"/>
-          <a:chExt cx="0" cy="0"/>
-        </a:xfrm>
-      </p:grpSpPr>
-      <p:sp>
-        <p:nvSpPr>
-          <p:cNvPr id="2" name="Title 1">
-            <a:extLst>
-              <a:ext uri="{FF2B5EF4-FFF2-40B4-BE49-F238E27FC236}">
-                <a16:creationId xmlns:a16="http://schemas.microsoft.com/office/drawing/2014/main" id="{43A6E3B2-A397-A033-190D-C4D0CAB4ED81}"/>
-              </a:ext>
-            </a:extLst>
-          </p:cNvPr>
-          <p:cNvSpPr>
-            <a:spLocks noGrp="1"/>
-          </p:cNvSpPr>
-          <p:nvPr>
-            <p:ph type="title"/>
-          </p:nvPr>
-        </p:nvSpPr>
-        <p:spPr/>
-        <p:txBody>
-          <a:bodyPr/>
-          <a:lstStyle/>
-          <a:p>
-            <a:r>
-              <a:rPr lang="en-CA" dirty="0"/>
-              <a:t>In-Class Participation</a:t>
-            </a:r>
-          </a:p>
-        </p:txBody>
-      </p:sp>
-      <p:sp>
-        <p:nvSpPr>
-          <p:cNvPr id="4" name="Content Placeholder 3">
-            <a:extLst>
-              <a:ext uri="{FF2B5EF4-FFF2-40B4-BE49-F238E27FC236}">
-                <a16:creationId xmlns:a16="http://schemas.microsoft.com/office/drawing/2014/main" id="{EC56DA0F-3AE5-1CF6-8797-1397F0F6F9DD}"/>
-              </a:ext>
-            </a:extLst>
-          </p:cNvPr>
-          <p:cNvSpPr>
-            <a:spLocks noGrp="1" noChangeArrowheads="1"/>
-          </p:cNvSpPr>
-          <p:nvPr>
-            <p:ph idx="1"/>
-          </p:nvPr>
-        </p:nvSpPr>
-        <p:spPr bwMode="auto">
-          <a:xfrm>
-            <a:off x="2243662" y="2625518"/>
-            <a:ext cx="7729728" cy="369332"/>
-          </a:xfrm>
-          <a:prstGeom prst="rect">
-            <a:avLst/>
-          </a:prstGeom>
-          <a:noFill/>
-          <a:ln>
-            <a:noFill/>
-          </a:ln>
-          <a:effectLst/>
-          <a:extLst>
-            <a:ext uri="{909E8E84-426E-40DD-AFC4-6F175D3DCCD1}">
-              <a14:hiddenFill xmlns:a14="http://schemas.microsoft.com/office/drawing/2010/main">
-                <a:solidFill>
-                  <a:schemeClr val="accent1"/>
-                </a:solidFill>
-              </a14:hiddenFill>
-            </a:ext>
-            <a:ext uri="{91240B29-F687-4F45-9708-019B960494DF}">
-              <a14:hiddenLine xmlns:a14="http://schemas.microsoft.com/office/drawing/2010/main" w="9525">
-                <a:solidFill>
-                  <a:schemeClr val="tx1"/>
-                </a:solidFill>
-                <a:miter lim="800000"/>
-                <a:headEnd/>
-                <a:tailEnd/>
-              </a14:hiddenLine>
-            </a:ext>
-            <a:ext uri="{AF507438-7753-43E0-B8FC-AC1667EBCBE1}">
-              <a14:hiddenEffects xmlns:a14="http://schemas.microsoft.com/office/drawing/2010/main">
-                <a:effectLst>
-                  <a:outerShdw dist="35921" dir="2700000" algn="ctr" rotWithShape="0">
-                    <a:schemeClr val="bg2"/>
-                  </a:outerShdw>
-                </a:effectLst>
-              </a14:hiddenEffects>
-            </a:ext>
-          </a:extLst>
-        </p:spPr>
-        <p:txBody>
-          <a:bodyPr vert="horz" wrap="square" lIns="91440" tIns="45720" rIns="91440" bIns="45720" numCol="1" anchor="t" anchorCtr="0" compatLnSpc="1">
-            <a:prstTxWarp prst="textNoShape">
-              <a:avLst/>
-            </a:prstTxWarp>
-            <a:spAutoFit/>
-          </a:bodyPr>
-          <a:lstStyle/>
-          <a:p>
-            <a:pPr marL="0" marR="0" lvl="0" indent="0" algn="ctr" defTabSz="914400" rtl="0" eaLnBrk="0" fontAlgn="base" latinLnBrk="0" hangingPunct="0">
-              <a:lnSpc>
-                <a:spcPct val="100000"/>
-              </a:lnSpc>
-              <a:spcBef>
-                <a:spcPct val="0"/>
-              </a:spcBef>
-              <a:spcAft>
-                <a:spcPct val="0"/>
-              </a:spcAft>
-              <a:buClrTx/>
-              <a:buSzTx/>
-              <a:buFontTx/>
-              <a:buNone/>
-              <a:tabLst/>
-            </a:pPr>
-            <a:r>
-              <a:rPr kumimoji="0" lang="en-US" altLang="en-US" sz="1800" b="0" i="0" u="none" strike="noStrike" cap="none" normalizeH="0" baseline="0" dirty="0">
-                <a:ln>
-                  <a:noFill/>
-                </a:ln>
-                <a:solidFill>
-                  <a:schemeClr val="tx1"/>
-                </a:solidFill>
-                <a:effectLst/>
-                <a:latin typeface="Arial" panose="020B0604020202020204" pitchFamily="34" charset="0"/>
-                <a:hlinkClick r:id="rId2"/>
-              </a:rPr>
-              <a:t>2026W CS1910 In-Class Participation 01 – Fill out form</a:t>
-            </a:r>
-            <a:endParaRPr kumimoji="0" lang="en-US" altLang="en-US" sz="1800" b="0" i="0" u="none" strike="noStrike" cap="none" normalizeH="0" baseline="0" dirty="0">
-              <a:ln>
-                <a:noFill/>
-              </a:ln>
-              <a:solidFill>
-                <a:schemeClr val="tx1"/>
-              </a:solidFill>
-              <a:effectLst/>
-              <a:latin typeface="Arial" panose="020B0604020202020204" pitchFamily="34" charset="0"/>
-            </a:endParaRPr>
-          </a:p>
-        </p:txBody>
-      </p:sp>
-      <p:pic>
-        <p:nvPicPr>
-          <p:cNvPr id="1029" name="Picture 5" descr="QR code">
-            <a:extLst>
-              <a:ext uri="{FF2B5EF4-FFF2-40B4-BE49-F238E27FC236}">
-                <a16:creationId xmlns:a16="http://schemas.microsoft.com/office/drawing/2014/main" id="{2EC23380-9C11-9BCE-D223-10687D92178B}"/>
-              </a:ext>
-            </a:extLst>
-          </p:cNvPr>
-          <p:cNvPicPr>
-            <a:picLocks noChangeAspect="1" noChangeArrowheads="1"/>
-          </p:cNvPicPr>
-          <p:nvPr/>
-        </p:nvPicPr>
-        <p:blipFill>
-          <a:blip r:embed="rId3">
-            <a:extLst>
-              <a:ext uri="{28A0092B-C50C-407E-A947-70E740481C1C}">
-                <a14:useLocalDpi xmlns:a14="http://schemas.microsoft.com/office/drawing/2010/main" val="0"/>
-              </a:ext>
-            </a:extLst>
-          </a:blip>
-          <a:srcRect/>
-          <a:stretch>
-            <a:fillRect/>
-          </a:stretch>
-        </p:blipFill>
-        <p:spPr bwMode="auto">
-          <a:xfrm>
-            <a:off x="4525934" y="3040420"/>
-            <a:ext cx="2852888" cy="2852888"/>
-          </a:xfrm>
-          <a:prstGeom prst="rect">
-            <a:avLst/>
-          </a:prstGeom>
-          <a:noFill/>
-          <a:extLst>
-            <a:ext uri="{909E8E84-426E-40DD-AFC4-6F175D3DCCD1}">
-              <a14:hiddenFill xmlns:a14="http://schemas.microsoft.com/office/drawing/2010/main">
-                <a:solidFill>
-                  <a:srgbClr val="FFFFFF"/>
-                </a:solidFill>
-              </a14:hiddenFill>
-            </a:ext>
-          </a:extLst>
-        </p:spPr>
-      </p:pic>
-    </p:spTree>
-    <p:extLst>
-      <p:ext uri="{BB962C8B-B14F-4D97-AF65-F5344CB8AC3E}">
-        <p14:creationId xmlns:p14="http://schemas.microsoft.com/office/powerpoint/2010/main" val="68935377"/>
-      </p:ext>
-    </p:extLst>
-  </p:cSld>
-  <p:clrMapOvr>
-    <a:masterClrMapping/>
-  </p:clrMapOvr>
-</p:sld>
-</file>
-
-<file path=ppt/slides/slide33.xml><?xml version="1.0" encoding="utf-8"?>
 <p:sld xmlns:a="http://schemas.openxmlformats.org/drawingml/2006/main" xmlns:r="http://schemas.openxmlformats.org/officeDocument/2006/relationships" xmlns:p="http://schemas.openxmlformats.org/presentationml/2006/main">
   <p:cSld>
     <p:bg>
@@ -14196,7 +14099,7 @@
 </p:sld>
 </file>
 
-<file path=ppt/slides/slide34.xml><?xml version="1.0" encoding="utf-8"?>
+<file path=ppt/slides/slide33.xml><?xml version="1.0" encoding="utf-8"?>
 <p:sld xmlns:a="http://schemas.openxmlformats.org/drawingml/2006/main" xmlns:r="http://schemas.openxmlformats.org/officeDocument/2006/relationships" xmlns:p="http://schemas.openxmlformats.org/presentationml/2006/main">
   <p:cSld>
     <p:bg>
@@ -14408,7 +14311,7 @@
 </p:sld>
 </file>
 
-<file path=ppt/slides/slide35.xml><?xml version="1.0" encoding="utf-8"?>
+<file path=ppt/slides/slide34.xml><?xml version="1.0" encoding="utf-8"?>
 <p:sld xmlns:a="http://schemas.openxmlformats.org/drawingml/2006/main" xmlns:r="http://schemas.openxmlformats.org/officeDocument/2006/relationships" xmlns:p="http://schemas.openxmlformats.org/presentationml/2006/main">
   <p:cSld>
     <p:bg>
@@ -14755,7 +14658,7 @@
 </p:sld>
 </file>
 
-<file path=ppt/slides/slide36.xml><?xml version="1.0" encoding="utf-8"?>
+<file path=ppt/slides/slide35.xml><?xml version="1.0" encoding="utf-8"?>
 <p:sld xmlns:a="http://schemas.openxmlformats.org/drawingml/2006/main" xmlns:r="http://schemas.openxmlformats.org/officeDocument/2006/relationships" xmlns:p="http://schemas.openxmlformats.org/presentationml/2006/main">
   <p:cSld>
     <p:bg>
@@ -15098,7 +15001,7 @@
 </p:sld>
 </file>
 
-<file path=ppt/slides/slide37.xml><?xml version="1.0" encoding="utf-8"?>
+<file path=ppt/slides/slide36.xml><?xml version="1.0" encoding="utf-8"?>
 <p:sld xmlns:a="http://schemas.openxmlformats.org/drawingml/2006/main" xmlns:r="http://schemas.openxmlformats.org/officeDocument/2006/relationships" xmlns:p="http://schemas.openxmlformats.org/presentationml/2006/main">
   <p:cSld>
     <p:bg>
@@ -15488,7 +15391,7 @@
 </p:sld>
 </file>
 
-<file path=ppt/slides/slide38.xml><?xml version="1.0" encoding="utf-8"?>
+<file path=ppt/slides/slide37.xml><?xml version="1.0" encoding="utf-8"?>
 <p:sld xmlns:a="http://schemas.openxmlformats.org/drawingml/2006/main" xmlns:r="http://schemas.openxmlformats.org/officeDocument/2006/relationships" xmlns:p="http://schemas.openxmlformats.org/presentationml/2006/main">
   <p:cSld>
     <p:bg>
@@ -15717,7 +15620,7 @@
 </p:sld>
 </file>
 
-<file path=ppt/slides/slide39.xml><?xml version="1.0" encoding="utf-8"?>
+<file path=ppt/slides/slide38.xml><?xml version="1.0" encoding="utf-8"?>
 <p:sld xmlns:a="http://schemas.openxmlformats.org/drawingml/2006/main" xmlns:r="http://schemas.openxmlformats.org/officeDocument/2006/relationships" xmlns:p="http://schemas.openxmlformats.org/presentationml/2006/main">
   <p:cSld>
     <p:bg>
@@ -15989,8 +15892,8 @@
         </p:nvSpPr>
         <p:spPr>
           <a:xfrm>
-            <a:off x="2231135" y="2349584"/>
-            <a:ext cx="3042215" cy="2862322"/>
+            <a:off x="2231136" y="2229753"/>
+            <a:ext cx="7729728" cy="4185761"/>
           </a:xfrm>
           <a:prstGeom prst="rect">
             <a:avLst/>
@@ -16009,196 +15912,190 @@
           <a:lstStyle/>
           <a:p>
             <a:r>
-              <a:rPr lang="en-US" u="sng" dirty="0"/>
-              <a:t>Course Instructor</a:t>
-            </a:r>
-          </a:p>
-          <a:p>
-            <a:endParaRPr lang="en-US" u="sng" dirty="0"/>
-          </a:p>
-          <a:p>
-            <a:r>
-              <a:rPr lang="en-US" dirty="0"/>
-              <a:t>Christopher Power</a:t>
-            </a:r>
-          </a:p>
-          <a:p>
-            <a:r>
-              <a:rPr lang="en-US" dirty="0"/>
-              <a:t>CSH 208</a:t>
-            </a:r>
-          </a:p>
-          <a:p>
-            <a:r>
-              <a:rPr lang="en-US" dirty="0">
-                <a:hlinkClick r:id="rId2"/>
-              </a:rPr>
-              <a:t>cdspower@upei.ca</a:t>
-            </a:r>
-            <a:endParaRPr lang="en-US" dirty="0"/>
-          </a:p>
-          <a:p>
-            <a:endParaRPr lang="en-US" dirty="0"/>
-          </a:p>
-          <a:p>
-            <a:r>
-              <a:rPr lang="en-US" dirty="0"/>
+              <a:rPr lang="en-US" sz="1400" b="1" dirty="0"/>
+              <a:t>2026F-CS1910-01</a:t>
+            </a:r>
+            <a:endParaRPr lang="en-CA" sz="1400" b="1" dirty="0"/>
+          </a:p>
+          <a:p>
+            <a:r>
+              <a:rPr lang="en-US" sz="1400" b="1" dirty="0"/>
+              <a:t>Instructor:</a:t>
+            </a:r>
+            <a:r>
+              <a:rPr lang="en-US" sz="1400" dirty="0"/>
+              <a:t> Christopher Power</a:t>
+            </a:r>
+            <a:endParaRPr lang="en-CA" sz="1400" dirty="0"/>
+          </a:p>
+          <a:p>
+            <a:r>
+              <a:rPr lang="en-US" sz="1400" b="1" dirty="0"/>
+              <a:t>Office:</a:t>
+            </a:r>
+            <a:r>
+              <a:rPr lang="en-US" sz="1400" dirty="0"/>
+              <a:t> Cass Science Hall 208 (Just inside the main SMCS Office)</a:t>
+            </a:r>
+            <a:endParaRPr lang="en-CA" sz="1400" dirty="0"/>
+          </a:p>
+          <a:p>
+            <a:r>
+              <a:rPr lang="en-US" sz="1400" b="1" dirty="0"/>
+              <a:t>Email:</a:t>
+            </a:r>
+            <a:r>
+              <a:rPr lang="en-US" sz="1400" dirty="0"/>
+              <a:t> cdspower@upei.ca</a:t>
+            </a:r>
+            <a:endParaRPr lang="en-CA" sz="1400" dirty="0"/>
+          </a:p>
+          <a:p>
+            <a:r>
+              <a:rPr lang="en-US" sz="1400" b="1" dirty="0"/>
+              <a:t>Lectures:</a:t>
+            </a:r>
+            <a:r>
+              <a:rPr lang="en-US" sz="1400" dirty="0"/>
+              <a:t> T/Th 8:30 AM - 9:45 PM</a:t>
+            </a:r>
+            <a:endParaRPr lang="en-CA" sz="1400" dirty="0"/>
+          </a:p>
+          <a:p>
+            <a:r>
+              <a:rPr lang="en-US" sz="1400" b="1" dirty="0"/>
               <a:t>Office Hours:</a:t>
             </a:r>
-          </a:p>
-          <a:p>
-            <a:endParaRPr lang="en-US" dirty="0"/>
-          </a:p>
-          <a:p>
-            <a:r>
-              <a:rPr lang="en-US" dirty="0"/>
-              <a:t>Wednesdays: 9:30-10:30</a:t>
-            </a:r>
-          </a:p>
-          <a:p>
-            <a:endParaRPr lang="en-US" dirty="0"/>
-          </a:p>
-        </p:txBody>
-      </p:sp>
-      <p:sp>
-        <p:nvSpPr>
-          <p:cNvPr id="5" name="TextBox 4">
-            <a:extLst>
-              <a:ext uri="{FF2B5EF4-FFF2-40B4-BE49-F238E27FC236}">
-                <a16:creationId xmlns:a16="http://schemas.microsoft.com/office/drawing/2014/main" id="{879FD1B7-91FD-12C1-8726-81861BE9F222}"/>
-              </a:ext>
-            </a:extLst>
-          </p:cNvPr>
-          <p:cNvSpPr txBox="1"/>
-          <p:nvPr/>
-        </p:nvSpPr>
-        <p:spPr>
-          <a:xfrm>
-            <a:off x="3965769" y="5615335"/>
-            <a:ext cx="4260462" cy="369332"/>
-          </a:xfrm>
-          <a:prstGeom prst="rect">
-            <a:avLst/>
-          </a:prstGeom>
-          <a:noFill/>
-          <a:ln>
-            <a:solidFill>
-              <a:srgbClr val="404040"/>
-            </a:solidFill>
-          </a:ln>
-        </p:spPr>
-        <p:txBody>
-          <a:bodyPr wrap="none" rtlCol="0">
-            <a:spAutoFit/>
-          </a:bodyPr>
-          <a:lstStyle/>
-          <a:p>
-            <a:r>
-              <a:rPr lang="en-US" dirty="0"/>
-              <a:t>Appointments outside office hours by email</a:t>
-            </a:r>
-          </a:p>
-        </p:txBody>
-      </p:sp>
-      <p:sp>
-        <p:nvSpPr>
-          <p:cNvPr id="7" name="Content Placeholder 6">
-            <a:extLst>
-              <a:ext uri="{FF2B5EF4-FFF2-40B4-BE49-F238E27FC236}">
-                <a16:creationId xmlns:a16="http://schemas.microsoft.com/office/drawing/2014/main" id="{DB9FA9FD-CC52-3EE2-5FCD-EAA2667B2044}"/>
-              </a:ext>
-            </a:extLst>
-          </p:cNvPr>
-          <p:cNvSpPr>
-            <a:spLocks noGrp="1"/>
-          </p:cNvSpPr>
-          <p:nvPr>
-            <p:ph idx="1"/>
-          </p:nvPr>
-        </p:nvSpPr>
-        <p:spPr>
-          <a:xfrm>
-            <a:off x="6918649" y="2229753"/>
-            <a:ext cx="3042215" cy="3101983"/>
-          </a:xfrm>
-          <a:ln>
-            <a:solidFill>
-              <a:srgbClr val="404040"/>
-            </a:solidFill>
-          </a:ln>
-        </p:spPr>
-        <p:txBody>
-          <a:bodyPr>
-            <a:normAutofit/>
-          </a:bodyPr>
-          <a:lstStyle/>
-          <a:p>
-            <a:pPr marL="0" indent="0">
-              <a:buNone/>
-            </a:pPr>
-            <a:r>
-              <a:rPr lang="en-US" dirty="0"/>
-              <a:t>Lab Instructors:</a:t>
-            </a:r>
-          </a:p>
-          <a:p>
-            <a:pPr marL="0" indent="0">
-              <a:buNone/>
-            </a:pPr>
-            <a:r>
-              <a:rPr lang="en-US" dirty="0"/>
-              <a:t>Chris Vessey </a:t>
-            </a:r>
-          </a:p>
-          <a:p>
-            <a:pPr marL="0" indent="0">
-              <a:buNone/>
-            </a:pPr>
-            <a:r>
-              <a:rPr lang="en-US" dirty="0">
-                <a:hlinkClick r:id="rId3"/>
-              </a:rPr>
-              <a:t>cvessey@upei.ca</a:t>
-            </a:r>
-            <a:endParaRPr lang="en-US" dirty="0"/>
-          </a:p>
-          <a:p>
-            <a:pPr marL="0" indent="0">
-              <a:buNone/>
-            </a:pPr>
-            <a:r>
-              <a:rPr lang="en-US" dirty="0"/>
-              <a:t>Taif Al </a:t>
-            </a:r>
-            <a:r>
-              <a:rPr lang="en-US" dirty="0" err="1"/>
-              <a:t>Musabe</a:t>
-            </a:r>
-            <a:r>
-              <a:rPr lang="en-US" dirty="0"/>
-              <a:t> </a:t>
-            </a:r>
-          </a:p>
-          <a:p>
-            <a:pPr marL="0" indent="0">
-              <a:buNone/>
-            </a:pPr>
-            <a:r>
-              <a:rPr lang="en-US" dirty="0">
-                <a:hlinkClick r:id="rId4"/>
-              </a:rPr>
-              <a:t>tamusable@upei.ca</a:t>
-            </a:r>
-            <a:endParaRPr lang="en-US" dirty="0"/>
-          </a:p>
-          <a:p>
-            <a:pPr marL="0" indent="0">
-              <a:buNone/>
-            </a:pPr>
-            <a:r>
-              <a:rPr lang="en-US" dirty="0"/>
-              <a:t>All labs occur on the same day as class.</a:t>
-            </a:r>
+            <a:r>
+              <a:rPr lang="en-US" sz="1400" dirty="0"/>
+              <a:t> Wednesdays 10:30 AM-11:30 AM or email to schedule a meeting</a:t>
+            </a:r>
+            <a:endParaRPr lang="en-CA" sz="1400" dirty="0"/>
+          </a:p>
+          <a:p>
+            <a:r>
+              <a:rPr lang="en-US" sz="1400" dirty="0"/>
+              <a:t> </a:t>
+            </a:r>
+            <a:endParaRPr lang="en-CA" sz="1400" dirty="0"/>
+          </a:p>
+          <a:p>
+            <a:r>
+              <a:rPr lang="en-US" sz="1400" b="1" dirty="0"/>
+              <a:t>2026F-CS1910-02</a:t>
+            </a:r>
+            <a:endParaRPr lang="en-CA" sz="1400" b="1" dirty="0"/>
+          </a:p>
+          <a:p>
+            <a:r>
+              <a:rPr lang="en-US" sz="1400" b="1" dirty="0"/>
+              <a:t>Instructor:</a:t>
+            </a:r>
+            <a:r>
+              <a:rPr lang="en-US" sz="1400" dirty="0"/>
+              <a:t> Dania Tamayo-Vera</a:t>
+            </a:r>
+            <a:endParaRPr lang="en-CA" sz="1400" dirty="0"/>
+          </a:p>
+          <a:p>
+            <a:r>
+              <a:rPr lang="en-US" sz="1400" b="1" dirty="0"/>
+              <a:t>Office:</a:t>
+            </a:r>
+            <a:r>
+              <a:rPr lang="en-US" sz="1400" dirty="0"/>
+              <a:t> Cass Science Hall 203F </a:t>
+            </a:r>
+            <a:endParaRPr lang="en-CA" sz="1400" dirty="0"/>
+          </a:p>
+          <a:p>
+            <a:r>
+              <a:rPr lang="en-US" sz="1400" b="1" dirty="0"/>
+              <a:t>Email:</a:t>
+            </a:r>
+            <a:r>
+              <a:rPr lang="en-US" sz="1400" dirty="0"/>
+              <a:t> dtamayovera@upei.ca</a:t>
+            </a:r>
+            <a:endParaRPr lang="en-CA" sz="1400" dirty="0"/>
+          </a:p>
+          <a:p>
+            <a:r>
+              <a:rPr lang="en-US" sz="1400" b="1" dirty="0"/>
+              <a:t>Lectures:</a:t>
+            </a:r>
+            <a:r>
+              <a:rPr lang="en-US" sz="1400" dirty="0"/>
+              <a:t> T/Th 8:30 AM - 9:45 PM</a:t>
+            </a:r>
+            <a:endParaRPr lang="en-CA" sz="1400" dirty="0"/>
+          </a:p>
+          <a:p>
+            <a:r>
+              <a:rPr lang="en-US" sz="1400" b="1" dirty="0"/>
+              <a:t>Office Hours:</a:t>
+            </a:r>
+            <a:r>
+              <a:rPr lang="en-US" sz="1400" dirty="0"/>
+              <a:t> Wednesdays 12:45 PM -2:15 PM or email to schedule a meeting</a:t>
+            </a:r>
+          </a:p>
+          <a:p>
+            <a:endParaRPr lang="en-US" sz="1400" dirty="0"/>
+          </a:p>
+          <a:p>
+            <a:r>
+              <a:rPr lang="en-CA" sz="1400" b="1" dirty="0"/>
+              <a:t>Labs:</a:t>
+            </a:r>
+          </a:p>
+          <a:p>
+            <a:r>
+              <a:rPr lang="en-US" sz="1400" b="1" dirty="0"/>
+              <a:t>Instructor:</a:t>
+            </a:r>
+            <a:r>
+              <a:rPr lang="en-US" sz="1400" dirty="0"/>
+              <a:t> Chris Vessey</a:t>
+            </a:r>
+            <a:endParaRPr lang="en-CA" sz="1400" dirty="0"/>
+          </a:p>
+          <a:p>
+            <a:r>
+              <a:rPr lang="en-US" sz="1400" b="1" dirty="0"/>
+              <a:t>Office:</a:t>
+            </a:r>
+            <a:r>
+              <a:rPr lang="en-US" sz="1400" dirty="0"/>
+              <a:t> Cass Science Hall 308</a:t>
+            </a:r>
+            <a:endParaRPr lang="en-CA" sz="1400" dirty="0"/>
+          </a:p>
+          <a:p>
+            <a:r>
+              <a:rPr lang="en-US" sz="1400" b="1" dirty="0"/>
+              <a:t>Email:</a:t>
+            </a:r>
+            <a:r>
+              <a:rPr lang="en-US" sz="1400" dirty="0"/>
+              <a:t> cvessey@upei.ca</a:t>
+            </a:r>
+            <a:endParaRPr lang="en-CA" sz="1400" dirty="0"/>
+          </a:p>
+          <a:p>
+            <a:r>
+              <a:rPr lang="en-US" sz="1400" b="1" dirty="0"/>
+              <a:t>Lab Times:</a:t>
+            </a:r>
+            <a:r>
+              <a:rPr lang="en-US" sz="1400" dirty="0"/>
+              <a:t> 3 sections </a:t>
+            </a:r>
+            <a:r>
+              <a:rPr lang="en-CA" sz="1400" b="1" dirty="0"/>
+              <a:t>Most weeks starting in week 2; CSH 104</a:t>
+            </a:r>
+            <a:endParaRPr lang="en-CA" sz="1400" dirty="0"/>
           </a:p>
         </p:txBody>
       </p:sp>
@@ -16211,162 +16108,6 @@
   </p:cSld>
   <p:clrMapOvr>
     <a:masterClrMapping/>
-  </p:clrMapOvr>
-</p:sld>
-</file>
-
-<file path=ppt/slides/slide40.xml><?xml version="1.0" encoding="utf-8"?>
-<p:sld xmlns:a="http://schemas.openxmlformats.org/drawingml/2006/main" xmlns:r="http://schemas.openxmlformats.org/officeDocument/2006/relationships" xmlns:p="http://schemas.openxmlformats.org/presentationml/2006/main" show="0">
-  <p:cSld>
-    <p:bg>
-      <p:bgPr>
-        <a:solidFill>
-          <a:schemeClr val="bg2">
-            <a:tint val="95000"/>
-            <a:satMod val="170000"/>
-          </a:schemeClr>
-        </a:solidFill>
-        <a:effectLst/>
-      </p:bgPr>
-    </p:bg>
-    <p:spTree>
-      <p:nvGrpSpPr>
-        <p:cNvPr id="1" name=""/>
-        <p:cNvGrpSpPr/>
-        <p:nvPr/>
-      </p:nvGrpSpPr>
-      <p:grpSpPr>
-        <a:xfrm>
-          <a:off x="0" y="0"/>
-          <a:ext cx="0" cy="0"/>
-          <a:chOff x="0" y="0"/>
-          <a:chExt cx="0" cy="0"/>
-        </a:xfrm>
-      </p:grpSpPr>
-      <p:sp>
-        <p:nvSpPr>
-          <p:cNvPr id="2" name="Title 1">
-            <a:extLst>
-              <a:ext uri="{FF2B5EF4-FFF2-40B4-BE49-F238E27FC236}">
-                <a16:creationId xmlns:a16="http://schemas.microsoft.com/office/drawing/2014/main" id="{14B54E06-C152-D0EC-614F-B348C2304CF4}"/>
-              </a:ext>
-            </a:extLst>
-          </p:cNvPr>
-          <p:cNvSpPr>
-            <a:spLocks noGrp="1"/>
-          </p:cNvSpPr>
-          <p:nvPr>
-            <p:ph type="title"/>
-          </p:nvPr>
-        </p:nvSpPr>
-        <p:spPr>
-          <a:xfrm>
-            <a:off x="1600200" y="2286000"/>
-            <a:ext cx="8991600" cy="1828800"/>
-          </a:xfrm>
-          <a:noFill/>
-          <a:ln>
-            <a:solidFill>
-              <a:schemeClr val="tx1"/>
-            </a:solidFill>
-          </a:ln>
-        </p:spPr>
-        <p:txBody>
-          <a:bodyPr vert="horz" lIns="274320" tIns="182880" rIns="274320" bIns="182880" rtlCol="0" anchor="ctr" anchorCtr="1">
-            <a:normAutofit/>
-          </a:bodyPr>
-          <a:lstStyle/>
-          <a:p>
-            <a:r>
-              <a:rPr lang="en-US" sz="3200" kern="1200" cap="all" spc="200" baseline="0">
-                <a:solidFill>
-                  <a:schemeClr val="tx1"/>
-                </a:solidFill>
-                <a:latin typeface="+mj-lt"/>
-                <a:ea typeface="+mj-ea"/>
-                <a:cs typeface="+mj-cs"/>
-              </a:rPr>
-              <a:t>Homework</a:t>
-            </a:r>
-          </a:p>
-        </p:txBody>
-      </p:sp>
-      <p:sp>
-        <p:nvSpPr>
-          <p:cNvPr id="3" name="Content Placeholder 2">
-            <a:extLst>
-              <a:ext uri="{FF2B5EF4-FFF2-40B4-BE49-F238E27FC236}">
-                <a16:creationId xmlns:a16="http://schemas.microsoft.com/office/drawing/2014/main" id="{FEE3FCB7-06F0-BB04-824F-273D53FDD97C}"/>
-              </a:ext>
-            </a:extLst>
-          </p:cNvPr>
-          <p:cNvSpPr>
-            <a:spLocks noGrp="1"/>
-          </p:cNvSpPr>
-          <p:nvPr>
-            <p:ph idx="1"/>
-          </p:nvPr>
-        </p:nvSpPr>
-        <p:spPr>
-          <a:xfrm>
-            <a:off x="2695194" y="4483290"/>
-            <a:ext cx="6801612" cy="1329208"/>
-          </a:xfrm>
-        </p:spPr>
-        <p:txBody>
-          <a:bodyPr vert="horz" lIns="91440" tIns="45720" rIns="91440" bIns="45720" rtlCol="0">
-            <a:normAutofit/>
-          </a:bodyPr>
-          <a:lstStyle/>
-          <a:p>
-            <a:pPr marL="0" indent="0" algn="ctr">
-              <a:buNone/>
-            </a:pPr>
-            <a:r>
-              <a:rPr lang="en-US" sz="2000" dirty="0">
-                <a:solidFill>
-                  <a:schemeClr val="tx1">
-                    <a:lumMod val="75000"/>
-                    <a:lumOff val="25000"/>
-                  </a:schemeClr>
-                </a:solidFill>
-                <a:hlinkClick r:id="rId2"/>
-              </a:rPr>
-              <a:t>https://colab.research.google.com/github/andrewgodbout/F2025CS1910/blob/main/homework/HW1/HW-01.ipynb#scrollTo=VgI7e_ITIMij</a:t>
-            </a:r>
-            <a:endParaRPr lang="en-US" sz="2000" dirty="0">
-              <a:solidFill>
-                <a:schemeClr val="tx1">
-                  <a:lumMod val="75000"/>
-                  <a:lumOff val="25000"/>
-                </a:schemeClr>
-              </a:solidFill>
-            </a:endParaRPr>
-          </a:p>
-          <a:p>
-            <a:pPr marL="0" indent="0" algn="ctr">
-              <a:buNone/>
-            </a:pPr>
-            <a:endParaRPr lang="en-US" sz="2000" dirty="0">
-              <a:solidFill>
-                <a:schemeClr val="tx1">
-                  <a:lumMod val="75000"/>
-                  <a:lumOff val="25000"/>
-                </a:schemeClr>
-              </a:solidFill>
-            </a:endParaRPr>
-          </a:p>
-        </p:txBody>
-      </p:sp>
-    </p:spTree>
-    <p:extLst>
-      <p:ext uri="{BB962C8B-B14F-4D97-AF65-F5344CB8AC3E}">
-        <p14:creationId xmlns:p14="http://schemas.microsoft.com/office/powerpoint/2010/main" val="4168177853"/>
-      </p:ext>
-    </p:extLst>
-  </p:cSld>
-  <p:clrMapOvr>
-    <a:overrideClrMapping bg1="dk1" tx1="lt1" bg2="dk2" tx2="lt2" accent1="accent1" accent2="accent2" accent3="accent3" accent4="accent4" accent5="accent5" accent6="accent6" hlink="hlink" folHlink="folHlink"/>
   </p:clrMapOvr>
 </p:sld>
 </file>
@@ -16915,14 +16656,14 @@
           <p:nvPr>
             <p:extLst>
               <p:ext uri="{D42A27DB-BD31-4B8C-83A1-F6EECF244321}">
-                <p14:modId xmlns:p14="http://schemas.microsoft.com/office/powerpoint/2010/main" val="1740483358"/>
+                <p14:modId xmlns:p14="http://schemas.microsoft.com/office/powerpoint/2010/main" val="1459279698"/>
               </p:ext>
             </p:extLst>
           </p:nvPr>
         </p:nvGraphicFramePr>
         <p:xfrm>
           <a:off x="2231136" y="2427612"/>
-          <a:ext cx="3567442" cy="3191496"/>
+          <a:ext cx="3567442" cy="2798737"/>
         </p:xfrm>
         <a:graphic>
           <a:graphicData uri="http://schemas.openxmlformats.org/drawingml/2006/table">
@@ -16987,7 +16728,7 @@
                     <a:p>
                       <a:r>
                         <a:rPr lang="en-US" dirty="0"/>
-                        <a:t>Final Exam</a:t>
+                        <a:t>Class Participation</a:t>
                       </a:r>
                     </a:p>
                   </a:txBody>
@@ -17001,7 +16742,7 @@
                       <a:pPr algn="r"/>
                       <a:r>
                         <a:rPr lang="en-US" dirty="0"/>
-                        <a:t>30%</a:t>
+                        <a:t>5%</a:t>
                       </a:r>
                     </a:p>
                   </a:txBody>
@@ -17021,7 +16762,75 @@
                     <a:p>
                       <a:r>
                         <a:rPr lang="en-US" dirty="0"/>
-                        <a:t>Test 1</a:t>
+                        <a:t>Homework</a:t>
+                      </a:r>
+                    </a:p>
+                  </a:txBody>
+                  <a:tcPr/>
+                </a:tc>
+                <a:tc>
+                  <a:txBody>
+                    <a:bodyPr/>
+                    <a:lstStyle/>
+                    <a:p>
+                      <a:pPr algn="r"/>
+                      <a:r>
+                        <a:rPr lang="en-US" dirty="0"/>
+                        <a:t>18%</a:t>
+                      </a:r>
+                    </a:p>
+                  </a:txBody>
+                  <a:tcPr/>
+                </a:tc>
+                <a:extLst>
+                  <a:ext uri="{0D108BD9-81ED-4DB2-BD59-A6C34878D82A}">
+                    <a16:rowId xmlns:a16="http://schemas.microsoft.com/office/drawing/2014/main" val="1539385009"/>
+                  </a:ext>
+                </a:extLst>
+              </a:tr>
+              <a:tr h="392759">
+                <a:tc>
+                  <a:txBody>
+                    <a:bodyPr/>
+                    <a:lstStyle/>
+                    <a:p>
+                      <a:r>
+                        <a:rPr lang="en-US" dirty="0"/>
+                        <a:t>Labs</a:t>
+                      </a:r>
+                    </a:p>
+                  </a:txBody>
+                  <a:tcPr/>
+                </a:tc>
+                <a:tc>
+                  <a:txBody>
+                    <a:bodyPr/>
+                    <a:lstStyle/>
+                    <a:p>
+                      <a:pPr algn="r"/>
+                      <a:r>
+                        <a:rPr lang="en-US" dirty="0"/>
+                        <a:t>12%</a:t>
+                      </a:r>
+                    </a:p>
+                  </a:txBody>
+                  <a:tcPr/>
+                </a:tc>
+                <a:extLst>
+                  <a:ext uri="{0D108BD9-81ED-4DB2-BD59-A6C34878D82A}">
+                    <a16:rowId xmlns:a16="http://schemas.microsoft.com/office/drawing/2014/main" val="3979907748"/>
+                  </a:ext>
+                </a:extLst>
+              </a:tr>
+              <a:tr h="392759">
+                <a:tc>
+                  <a:txBody>
+                    <a:bodyPr/>
+                    <a:lstStyle/>
+                    <a:p>
+                      <a:r>
+                        <a:rPr lang="en-US" dirty="0"/>
+                        <a:t>Midterm Test 1</a:t>
                       </a:r>
                     </a:p>
                   </a:txBody>
@@ -17055,7 +16864,7 @@
                     <a:p>
                       <a:r>
                         <a:rPr lang="en-US" dirty="0"/>
-                        <a:t>Test 2</a:t>
+                        <a:t>Midterm Test 2</a:t>
                       </a:r>
                     </a:p>
                   </a:txBody>
@@ -17087,9 +16896,26 @@
                     <a:bodyPr/>
                     <a:lstStyle/>
                     <a:p>
+                      <a:pPr marL="0" marR="0" lvl="0" indent="0" algn="l" defTabSz="914400" rtl="0" eaLnBrk="1" fontAlgn="auto" latinLnBrk="0" hangingPunct="1">
+                        <a:lnSpc>
+                          <a:spcPct val="100000"/>
+                        </a:lnSpc>
+                        <a:spcBef>
+                          <a:spcPts val="0"/>
+                        </a:spcBef>
+                        <a:spcAft>
+                          <a:spcPts val="0"/>
+                        </a:spcAft>
+                        <a:buClrTx/>
+                        <a:buSzTx/>
+                        <a:buFontTx/>
+                        <a:buNone/>
+                        <a:tabLst/>
+                        <a:defRPr/>
+                      </a:pPr>
                       <a:r>
                         <a:rPr lang="en-US" dirty="0"/>
-                        <a:t>Labs</a:t>
+                        <a:t>Final Exam</a:t>
                       </a:r>
                     </a:p>
                   </a:txBody>
@@ -17100,107 +16926,27 @@
                     <a:bodyPr/>
                     <a:lstStyle/>
                     <a:p>
-                      <a:pPr algn="r"/>
+                      <a:pPr marL="0" marR="0" lvl="0" indent="0" algn="r" defTabSz="914400" rtl="0" eaLnBrk="1" fontAlgn="auto" latinLnBrk="0" hangingPunct="1">
+                        <a:lnSpc>
+                          <a:spcPct val="100000"/>
+                        </a:lnSpc>
+                        <a:spcBef>
+                          <a:spcPts val="0"/>
+                        </a:spcBef>
+                        <a:spcAft>
+                          <a:spcPts val="0"/>
+                        </a:spcAft>
+                        <a:buClrTx/>
+                        <a:buSzTx/>
+                        <a:buFontTx/>
+                        <a:buNone/>
+                        <a:tabLst/>
+                        <a:defRPr/>
+                      </a:pPr>
                       <a:r>
                         <a:rPr lang="en-US" dirty="0"/>
-                        <a:t>18%</a:t>
+                        <a:t>35%</a:t>
                       </a:r>
-                    </a:p>
-                  </a:txBody>
-                  <a:tcPr/>
-                </a:tc>
-                <a:extLst>
-                  <a:ext uri="{0D108BD9-81ED-4DB2-BD59-A6C34878D82A}">
-                    <a16:rowId xmlns:a16="http://schemas.microsoft.com/office/drawing/2014/main" val="1527453213"/>
-                  </a:ext>
-                </a:extLst>
-              </a:tr>
-              <a:tr h="392759">
-                <a:tc>
-                  <a:txBody>
-                    <a:bodyPr/>
-                    <a:lstStyle/>
-                    <a:p>
-                      <a:r>
-                        <a:rPr lang="en-US" dirty="0"/>
-                        <a:t>Homework</a:t>
-                      </a:r>
-                    </a:p>
-                  </a:txBody>
-                  <a:tcPr/>
-                </a:tc>
-                <a:tc>
-                  <a:txBody>
-                    <a:bodyPr/>
-                    <a:lstStyle/>
-                    <a:p>
-                      <a:pPr algn="r"/>
-                      <a:r>
-                        <a:rPr lang="en-US" dirty="0"/>
-                        <a:t>18%</a:t>
-                      </a:r>
-                    </a:p>
-                  </a:txBody>
-                  <a:tcPr/>
-                </a:tc>
-                <a:extLst>
-                  <a:ext uri="{0D108BD9-81ED-4DB2-BD59-A6C34878D82A}">
-                    <a16:rowId xmlns:a16="http://schemas.microsoft.com/office/drawing/2014/main" val="1264804267"/>
-                  </a:ext>
-                </a:extLst>
-              </a:tr>
-              <a:tr h="392759">
-                <a:tc>
-                  <a:txBody>
-                    <a:bodyPr/>
-                    <a:lstStyle/>
-                    <a:p>
-                      <a:r>
-                        <a:rPr lang="en-US" dirty="0"/>
-                        <a:t>Class Participation</a:t>
-                      </a:r>
-                    </a:p>
-                  </a:txBody>
-                  <a:tcPr/>
-                </a:tc>
-                <a:tc>
-                  <a:txBody>
-                    <a:bodyPr/>
-                    <a:lstStyle/>
-                    <a:p>
-                      <a:pPr algn="r"/>
-                      <a:r>
-                        <a:rPr lang="en-US" dirty="0"/>
-                        <a:t>4%</a:t>
-                      </a:r>
-                    </a:p>
-                  </a:txBody>
-                  <a:tcPr/>
-                </a:tc>
-                <a:extLst>
-                  <a:ext uri="{0D108BD9-81ED-4DB2-BD59-A6C34878D82A}">
-                    <a16:rowId xmlns:a16="http://schemas.microsoft.com/office/drawing/2014/main" val="2371048774"/>
-                  </a:ext>
-                </a:extLst>
-              </a:tr>
-              <a:tr h="392759">
-                <a:tc>
-                  <a:txBody>
-                    <a:bodyPr/>
-                    <a:lstStyle/>
-                    <a:p>
-                      <a:endParaRPr lang="en-US" dirty="0"/>
-                    </a:p>
-                  </a:txBody>
-                  <a:tcPr/>
-                </a:tc>
-                <a:tc>
-                  <a:txBody>
-                    <a:bodyPr/>
-                    <a:lstStyle/>
-                    <a:p>
-                      <a:pPr algn="r"/>
-                      <a:endParaRPr lang="en-US" dirty="0"/>
                     </a:p>
                   </a:txBody>
                   <a:tcPr/>
@@ -17229,8 +16975,8 @@
         </p:nvSpPr>
         <p:spPr>
           <a:xfrm>
-            <a:off x="1549246" y="5800974"/>
-            <a:ext cx="9477343" cy="923330"/>
+            <a:off x="2231137" y="5393941"/>
+            <a:ext cx="7914088" cy="1200329"/>
           </a:xfrm>
           <a:prstGeom prst="rect">
             <a:avLst/>
@@ -17245,7 +16991,7 @@
           <a:p>
             <a:r>
               <a:rPr lang="en-US" dirty="0"/>
-              <a:t> You must pass the combined Tests (midterm 1, midterm 2 and final exam) to pass the course. 50% of your final grade is Tests, you must achieve at least 30% of your final grade from tests to pass the course. Otherwise your final grade is at most 45%.</a:t>
+              <a:t>You must pass the combined Tests (midterm 1, midterm 2 and final exam) to pass the course. 50% of your final grade is Tests, you must achieve at least 30% of your final grade from tests to pass the course. Otherwise your final grade is at most 45%.</a:t>
             </a:r>
           </a:p>
         </p:txBody>
@@ -17304,7 +17050,7 @@
         <p:spPr>
           <a:xfrm>
             <a:off x="7669996" y="3244334"/>
-            <a:ext cx="2304349" cy="369332"/>
+            <a:ext cx="2281715" cy="369332"/>
           </a:xfrm>
           <a:prstGeom prst="rect">
             <a:avLst/>
@@ -17319,7 +17065,7 @@
           <a:p>
             <a:r>
               <a:rPr lang="en-US" dirty="0"/>
-              <a:t>Date: February 9, 2026</a:t>
+              <a:t>Date: October 6, 2026</a:t>
             </a:r>
           </a:p>
         </p:txBody>
@@ -17378,7 +17124,7 @@
         <p:spPr>
           <a:xfrm>
             <a:off x="7669995" y="3654028"/>
-            <a:ext cx="2163734" cy="369332"/>
+            <a:ext cx="2475229" cy="369332"/>
           </a:xfrm>
           <a:prstGeom prst="rect">
             <a:avLst/>
@@ -17393,7 +17139,87 @@
           <a:p>
             <a:r>
               <a:rPr lang="en-US" dirty="0"/>
-              <a:t>Date: March 23, 2026</a:t>
+              <a:t>Date: November 3, 2026</a:t>
+            </a:r>
+          </a:p>
+        </p:txBody>
+      </p:sp>
+      <p:cxnSp>
+        <p:nvCxnSpPr>
+          <p:cNvPr id="3" name="Straight Arrow Connector 2">
+            <a:extLst>
+              <a:ext uri="{FF2B5EF4-FFF2-40B4-BE49-F238E27FC236}">
+                <a16:creationId xmlns:a16="http://schemas.microsoft.com/office/drawing/2014/main" id="{3A0A1E92-17C6-9156-053C-1DA2BC43C7F4}"/>
+              </a:ext>
+            </a:extLst>
+          </p:cNvPr>
+          <p:cNvCxnSpPr/>
+          <p:nvPr/>
+        </p:nvCxnSpPr>
+        <p:spPr>
+          <a:xfrm flipH="1">
+            <a:off x="5916706" y="5030856"/>
+            <a:ext cx="1635162" cy="0"/>
+          </a:xfrm>
+          <a:prstGeom prst="straightConnector1">
+            <a:avLst/>
+          </a:prstGeom>
+          <a:ln>
+            <a:tailEnd type="triangle"/>
+          </a:ln>
+        </p:spPr>
+        <p:style>
+          <a:lnRef idx="1">
+            <a:schemeClr val="accent1"/>
+          </a:lnRef>
+          <a:fillRef idx="0">
+            <a:schemeClr val="accent1"/>
+          </a:fillRef>
+          <a:effectRef idx="0">
+            <a:schemeClr val="accent1"/>
+          </a:effectRef>
+          <a:fontRef idx="minor">
+            <a:schemeClr val="tx1"/>
+          </a:fontRef>
+        </p:style>
+      </p:cxnSp>
+      <p:sp>
+        <p:nvSpPr>
+          <p:cNvPr id="5" name="TextBox 4">
+            <a:extLst>
+              <a:ext uri="{FF2B5EF4-FFF2-40B4-BE49-F238E27FC236}">
+                <a16:creationId xmlns:a16="http://schemas.microsoft.com/office/drawing/2014/main" id="{3194582F-8CBE-B3F5-8346-7A4D5AD6F5B1}"/>
+              </a:ext>
+            </a:extLst>
+          </p:cNvPr>
+          <p:cNvSpPr txBox="1"/>
+          <p:nvPr/>
+        </p:nvSpPr>
+        <p:spPr>
+          <a:xfrm>
+            <a:off x="7669995" y="4799581"/>
+            <a:ext cx="3059812" cy="646331"/>
+          </a:xfrm>
+          <a:prstGeom prst="rect">
+            <a:avLst/>
+          </a:prstGeom>
+          <a:noFill/>
+        </p:spPr>
+        <p:txBody>
+          <a:bodyPr wrap="none" rtlCol="0">
+            <a:spAutoFit/>
+          </a:bodyPr>
+          <a:lstStyle/>
+          <a:p>
+            <a:r>
+              <a:rPr lang="en-US" dirty="0"/>
+              <a:t>Date: During final exam period</a:t>
+            </a:r>
+          </a:p>
+          <a:p>
+            <a:r>
+              <a:rPr lang="en-US" dirty="0"/>
+              <a:t>Dec 11-23, 2026</a:t>
             </a:r>
           </a:p>
         </p:txBody>
@@ -17497,7 +17323,7 @@
           <a:p>
             <a:r>
               <a:rPr lang="en-US" dirty="0"/>
-              <a:t>It also allows us to allocate a large amount of points (40%) towards non-test grades so that students who struggle in testing environments can significantly boost their grade by performing well in other areas.</a:t>
+              <a:t>It also allows us to allocate a large number of points (35%) towards non-test grades so that students who struggle in testing environments can significantly boost their grade by performing well in other areas.</a:t>
             </a:r>
           </a:p>
           <a:p>

</xml_diff>